<commit_message>
DOC2 : captures récentes dans la présentation, les Word et le guide
Co-Authored-By: Claude Opus 5.5 <noreply@anthropic.com>
</commit_message>
<xml_diff>
--- a/docs/HuisClos-Presentation.pptx
+++ b/docs/HuisClos-Presentation.pptx
@@ -9833,12 +9833,12 @@
         </p:nvSpPr>
         <p:spPr>
           <a:xfrm>
-            <a:off x="548640" y="1554480"/>
-            <a:ext cx="3520440" cy="3291840"/>
+            <a:off x="548640" y="1371600"/>
+            <a:ext cx="3520440" cy="3794760"/>
           </a:xfrm>
           <a:prstGeom prst="roundRect">
             <a:avLst>
-              <a:gd name="adj" fmla="val 6000"/>
+              <a:gd name="adj" fmla="val 5000"/>
             </a:avLst>
           </a:prstGeom>
           <a:solidFill>
@@ -9869,16 +9869,40 @@
           <a:p/>
         </p:txBody>
       </p:sp>
-      <p:sp>
-        <p:nvSpPr>
-          <p:cNvPr id="7" name="Oval 6"/>
+      <p:pic>
+        <p:nvPicPr>
+          <p:cNvPr id="7" name="Picture 6" descr="Import step with a fictitious English text"/>
+          <p:cNvPicPr>
+            <a:picLocks noChangeAspect="1"/>
+          </p:cNvPicPr>
+          <p:nvPr/>
+        </p:nvPicPr>
+        <p:blipFill>
+          <a:blip r:embed="rId4"/>
+          <a:stretch>
+            <a:fillRect/>
+          </a:stretch>
+        </p:blipFill>
+        <p:spPr>
+          <a:xfrm>
+            <a:off x="777240" y="1572768"/>
+            <a:ext cx="3063240" cy="1808162"/>
+          </a:xfrm>
+          <a:prstGeom prst="rect">
+            <a:avLst/>
+          </a:prstGeom>
+        </p:spPr>
+      </p:pic>
+      <p:sp>
+        <p:nvSpPr>
+          <p:cNvPr id="8" name="Oval 7"/>
           <p:cNvSpPr/>
           <p:nvPr/>
         </p:nvSpPr>
         <p:spPr>
           <a:xfrm>
-            <a:off x="822959" y="1828800"/>
-            <a:ext cx="685800" cy="685800"/>
+            <a:off x="777240" y="3493008"/>
+            <a:ext cx="457200" cy="457200"/>
           </a:xfrm>
           <a:prstGeom prst="ellipse">
             <a:avLst/>
@@ -9911,7 +9935,7 @@
           <a:p>
             <a:pPr algn="ctr"/>
             <a:r>
-              <a:rPr sz="2200" b="1" i="0">
+              <a:rPr sz="1500" b="1" i="0">
                 <a:solidFill>
                   <a:srgbClr val="FFFFFF"/>
                 </a:solidFill>
@@ -9924,14 +9948,14 @@
       </p:sp>
       <p:sp>
         <p:nvSpPr>
-          <p:cNvPr id="8" name="TextBox 7"/>
+          <p:cNvPr id="9" name="TextBox 8"/>
           <p:cNvSpPr txBox="1"/>
           <p:nvPr/>
         </p:nvSpPr>
         <p:spPr>
           <a:xfrm>
-            <a:off x="822959" y="2697480"/>
-            <a:ext cx="3017520" cy="457200"/>
+            <a:off x="1371600" y="3493008"/>
+            <a:ext cx="2468880" cy="457200"/>
           </a:xfrm>
           <a:prstGeom prst="rect">
             <a:avLst/>
@@ -9939,7 +9963,7 @@
           <a:noFill/>
         </p:spPr>
         <p:txBody>
-          <a:bodyPr wrap="square" lIns="0" rIns="0" tIns="0" bIns="0" anchor="t">
+          <a:bodyPr wrap="square" lIns="0" rIns="0" tIns="0" bIns="0" anchor="ctr">
             <a:spAutoFit/>
           </a:bodyPr>
           <a:lstStyle/>
@@ -9950,7 +9974,7 @@
               </a:spcAft>
             </a:pPr>
             <a:r>
-              <a:rPr sz="2200" b="1" i="0">
+              <a:rPr sz="2000" b="1" i="0">
                 <a:solidFill>
                   <a:srgbClr val="1F3A5F"/>
                 </a:solidFill>
@@ -9963,14 +9987,14 @@
       </p:sp>
       <p:sp>
         <p:nvSpPr>
-          <p:cNvPr id="9" name="TextBox 8"/>
+          <p:cNvPr id="10" name="TextBox 9"/>
           <p:cNvSpPr txBox="1"/>
           <p:nvPr/>
         </p:nvSpPr>
         <p:spPr>
           <a:xfrm>
-            <a:off x="822959" y="3246120"/>
-            <a:ext cx="3017520" cy="1463040"/>
+            <a:off x="777240" y="4114800"/>
+            <a:ext cx="3063240" cy="1005840"/>
           </a:xfrm>
           <a:prstGeom prst="rect">
             <a:avLst/>
@@ -9989,7 +10013,7 @@
               </a:spcAft>
             </a:pPr>
             <a:r>
-              <a:rPr sz="1600" b="0" i="0">
+              <a:rPr sz="1500" b="0" i="0">
                 <a:solidFill>
                   <a:srgbClr val="1B2430"/>
                 </a:solidFill>
@@ -10002,18 +10026,18 @@
       </p:sp>
       <p:sp>
         <p:nvSpPr>
-          <p:cNvPr id="10" name="Rounded Rectangle 9"/>
+          <p:cNvPr id="11" name="Rounded Rectangle 10"/>
           <p:cNvSpPr/>
           <p:nvPr/>
         </p:nvSpPr>
         <p:spPr>
           <a:xfrm>
-            <a:off x="4343400" y="1554480"/>
-            <a:ext cx="3520440" cy="3291840"/>
+            <a:off x="4343400" y="1371600"/>
+            <a:ext cx="3520440" cy="3794760"/>
           </a:xfrm>
           <a:prstGeom prst="roundRect">
             <a:avLst>
-              <a:gd name="adj" fmla="val 6000"/>
+              <a:gd name="adj" fmla="val 5000"/>
             </a:avLst>
           </a:prstGeom>
           <a:solidFill>
@@ -10044,16 +10068,40 @@
           <a:p/>
         </p:txBody>
       </p:sp>
-      <p:sp>
-        <p:nvSpPr>
-          <p:cNvPr id="11" name="Oval 10"/>
+      <p:pic>
+        <p:nvPicPr>
+          <p:cNvPr id="12" name="Picture 11" descr="Review step: highlighted values of the fictitious sample case"/>
+          <p:cNvPicPr>
+            <a:picLocks noChangeAspect="1"/>
+          </p:cNvPicPr>
+          <p:nvPr/>
+        </p:nvPicPr>
+        <p:blipFill>
+          <a:blip r:embed="rId5"/>
+          <a:stretch>
+            <a:fillRect/>
+          </a:stretch>
+        </p:blipFill>
+        <p:spPr>
+          <a:xfrm>
+            <a:off x="4572000" y="1572768"/>
+            <a:ext cx="3063240" cy="1741932"/>
+          </a:xfrm>
+          <a:prstGeom prst="rect">
+            <a:avLst/>
+          </a:prstGeom>
+        </p:spPr>
+      </p:pic>
+      <p:sp>
+        <p:nvSpPr>
+          <p:cNvPr id="13" name="Oval 12"/>
           <p:cNvSpPr/>
           <p:nvPr/>
         </p:nvSpPr>
         <p:spPr>
           <a:xfrm>
-            <a:off x="4617720" y="1828800"/>
-            <a:ext cx="685800" cy="685800"/>
+            <a:off x="4572000" y="3493008"/>
+            <a:ext cx="457200" cy="457200"/>
           </a:xfrm>
           <a:prstGeom prst="ellipse">
             <a:avLst/>
@@ -10086,7 +10134,7 @@
           <a:p>
             <a:pPr algn="ctr"/>
             <a:r>
-              <a:rPr sz="2200" b="1" i="0">
+              <a:rPr sz="1500" b="1" i="0">
                 <a:solidFill>
                   <a:srgbClr val="FFFFFF"/>
                 </a:solidFill>
@@ -10099,14 +10147,14 @@
       </p:sp>
       <p:sp>
         <p:nvSpPr>
-          <p:cNvPr id="12" name="TextBox 11"/>
+          <p:cNvPr id="14" name="TextBox 13"/>
           <p:cNvSpPr txBox="1"/>
           <p:nvPr/>
         </p:nvSpPr>
         <p:spPr>
           <a:xfrm>
-            <a:off x="4617720" y="2697480"/>
-            <a:ext cx="3017520" cy="457200"/>
+            <a:off x="5166360" y="3493008"/>
+            <a:ext cx="2468880" cy="457200"/>
           </a:xfrm>
           <a:prstGeom prst="rect">
             <a:avLst/>
@@ -10114,7 +10162,7 @@
           <a:noFill/>
         </p:spPr>
         <p:txBody>
-          <a:bodyPr wrap="square" lIns="0" rIns="0" tIns="0" bIns="0" anchor="t">
+          <a:bodyPr wrap="square" lIns="0" rIns="0" tIns="0" bIns="0" anchor="ctr">
             <a:spAutoFit/>
           </a:bodyPr>
           <a:lstStyle/>
@@ -10125,7 +10173,7 @@
               </a:spcAft>
             </a:pPr>
             <a:r>
-              <a:rPr sz="2200" b="1" i="0">
+              <a:rPr sz="2000" b="1" i="0">
                 <a:solidFill>
                   <a:srgbClr val="1F3A5F"/>
                 </a:solidFill>
@@ -10138,14 +10186,14 @@
       </p:sp>
       <p:sp>
         <p:nvSpPr>
-          <p:cNvPr id="13" name="TextBox 12"/>
+          <p:cNvPr id="15" name="TextBox 14"/>
           <p:cNvSpPr txBox="1"/>
           <p:nvPr/>
         </p:nvSpPr>
         <p:spPr>
           <a:xfrm>
-            <a:off x="4617720" y="3246120"/>
-            <a:ext cx="3017520" cy="1463040"/>
+            <a:off x="4572000" y="4114800"/>
+            <a:ext cx="3063240" cy="1005840"/>
           </a:xfrm>
           <a:prstGeom prst="rect">
             <a:avLst/>
@@ -10164,7 +10212,7 @@
               </a:spcAft>
             </a:pPr>
             <a:r>
-              <a:rPr sz="1600" b="0" i="0">
+              <a:rPr sz="1500" b="0" i="0">
                 <a:solidFill>
                   <a:srgbClr val="1B2430"/>
                 </a:solidFill>
@@ -10177,18 +10225,18 @@
       </p:sp>
       <p:sp>
         <p:nvSpPr>
-          <p:cNvPr id="14" name="Rounded Rectangle 13"/>
+          <p:cNvPr id="16" name="Rounded Rectangle 15"/>
           <p:cNvSpPr/>
           <p:nvPr/>
         </p:nvSpPr>
         <p:spPr>
           <a:xfrm>
-            <a:off x="8138160" y="1554480"/>
-            <a:ext cx="3520440" cy="3291840"/>
+            <a:off x="8138160" y="1371600"/>
+            <a:ext cx="3520440" cy="3794760"/>
           </a:xfrm>
           <a:prstGeom prst="roundRect">
             <a:avLst>
-              <a:gd name="adj" fmla="val 6000"/>
+              <a:gd name="adj" fmla="val 5000"/>
             </a:avLst>
           </a:prstGeom>
           <a:solidFill>
@@ -10219,16 +10267,40 @@
           <a:p/>
         </p:txBody>
       </p:sp>
-      <p:sp>
-        <p:nvSpPr>
-          <p:cNvPr id="15" name="Oval 14"/>
+      <p:pic>
+        <p:nvPicPr>
+          <p:cNvPr id="17" name="Picture 16" descr="Restore step: restored answer with unknown and altered tokens"/>
+          <p:cNvPicPr>
+            <a:picLocks noChangeAspect="1"/>
+          </p:cNvPicPr>
+          <p:nvPr/>
+        </p:nvPicPr>
+        <p:blipFill>
+          <a:blip r:embed="rId6"/>
+          <a:stretch>
+            <a:fillRect/>
+          </a:stretch>
+        </p:blipFill>
+        <p:spPr>
+          <a:xfrm>
+            <a:off x="8366760" y="1572768"/>
+            <a:ext cx="3063240" cy="1742152"/>
+          </a:xfrm>
+          <a:prstGeom prst="rect">
+            <a:avLst/>
+          </a:prstGeom>
+        </p:spPr>
+      </p:pic>
+      <p:sp>
+        <p:nvSpPr>
+          <p:cNvPr id="18" name="Oval 17"/>
           <p:cNvSpPr/>
           <p:nvPr/>
         </p:nvSpPr>
         <p:spPr>
           <a:xfrm>
-            <a:off x="8412480" y="1828800"/>
-            <a:ext cx="685800" cy="685800"/>
+            <a:off x="8366760" y="3493008"/>
+            <a:ext cx="457200" cy="457200"/>
           </a:xfrm>
           <a:prstGeom prst="ellipse">
             <a:avLst/>
@@ -10261,7 +10333,7 @@
           <a:p>
             <a:pPr algn="ctr"/>
             <a:r>
-              <a:rPr sz="2200" b="1" i="0">
+              <a:rPr sz="1500" b="1" i="0">
                 <a:solidFill>
                   <a:srgbClr val="FFFFFF"/>
                 </a:solidFill>
@@ -10274,14 +10346,14 @@
       </p:sp>
       <p:sp>
         <p:nvSpPr>
-          <p:cNvPr id="16" name="TextBox 15"/>
+          <p:cNvPr id="19" name="TextBox 18"/>
           <p:cNvSpPr txBox="1"/>
           <p:nvPr/>
         </p:nvSpPr>
         <p:spPr>
           <a:xfrm>
-            <a:off x="8412480" y="2697480"/>
-            <a:ext cx="3017520" cy="457200"/>
+            <a:off x="8961120" y="3493008"/>
+            <a:ext cx="2468880" cy="457200"/>
           </a:xfrm>
           <a:prstGeom prst="rect">
             <a:avLst/>
@@ -10289,7 +10361,7 @@
           <a:noFill/>
         </p:spPr>
         <p:txBody>
-          <a:bodyPr wrap="square" lIns="0" rIns="0" tIns="0" bIns="0" anchor="t">
+          <a:bodyPr wrap="square" lIns="0" rIns="0" tIns="0" bIns="0" anchor="ctr">
             <a:spAutoFit/>
           </a:bodyPr>
           <a:lstStyle/>
@@ -10300,7 +10372,7 @@
               </a:spcAft>
             </a:pPr>
             <a:r>
-              <a:rPr sz="2200" b="1" i="0">
+              <a:rPr sz="2000" b="1" i="0">
                 <a:solidFill>
                   <a:srgbClr val="1F3A5F"/>
                 </a:solidFill>
@@ -10313,14 +10385,14 @@
       </p:sp>
       <p:sp>
         <p:nvSpPr>
-          <p:cNvPr id="17" name="TextBox 16"/>
+          <p:cNvPr id="20" name="TextBox 19"/>
           <p:cNvSpPr txBox="1"/>
           <p:nvPr/>
         </p:nvSpPr>
         <p:spPr>
           <a:xfrm>
-            <a:off x="8412480" y="3246120"/>
-            <a:ext cx="3017520" cy="1463040"/>
+            <a:off x="8366760" y="4114800"/>
+            <a:ext cx="3063240" cy="1005840"/>
           </a:xfrm>
           <a:prstGeom prst="rect">
             <a:avLst/>
@@ -10339,7 +10411,7 @@
               </a:spcAft>
             </a:pPr>
             <a:r>
-              <a:rPr sz="1600" b="0" i="0">
+              <a:rPr sz="1500" b="0" i="0">
                 <a:solidFill>
                   <a:srgbClr val="1B2430"/>
                 </a:solidFill>
@@ -10352,14 +10424,14 @@
       </p:sp>
       <p:sp>
         <p:nvSpPr>
-          <p:cNvPr id="18" name="Rounded Rectangle 17"/>
+          <p:cNvPr id="21" name="Rounded Rectangle 20"/>
           <p:cNvSpPr/>
           <p:nvPr/>
         </p:nvSpPr>
         <p:spPr>
           <a:xfrm>
-            <a:off x="548640" y="5166360"/>
-            <a:ext cx="11064240" cy="822960"/>
+            <a:off x="548640" y="5349240"/>
+            <a:ext cx="11064240" cy="731520"/>
           </a:xfrm>
           <a:prstGeom prst="roundRect">
             <a:avLst>
@@ -10396,14 +10468,14 @@
       </p:sp>
       <p:sp>
         <p:nvSpPr>
-          <p:cNvPr id="19" name="TextBox 18"/>
+          <p:cNvPr id="22" name="TextBox 21"/>
           <p:cNvSpPr txBox="1"/>
           <p:nvPr/>
         </p:nvSpPr>
         <p:spPr>
           <a:xfrm>
-            <a:off x="868680" y="5166360"/>
-            <a:ext cx="10424160" cy="822960"/>
+            <a:off x="868680" y="5349240"/>
+            <a:ext cx="10424160" cy="731520"/>
           </a:xfrm>
           <a:prstGeom prst="rect">
             <a:avLst/>
@@ -13787,7 +13859,7 @@
       </p:sp>
       <p:pic>
         <p:nvPicPr>
-          <p:cNvPr id="6" name="Picture 5" descr="Review step: fictitious case with highlighted values"/>
+          <p:cNvPr id="6" name="Picture 5" descr="Review step: highlighted values of the fictitious sample case"/>
           <p:cNvPicPr>
             <a:picLocks noChangeAspect="1"/>
           </p:cNvPicPr>
@@ -13802,23 +13874,47 @@
         <p:spPr>
           <a:xfrm>
             <a:off x="548640" y="1371600"/>
-            <a:ext cx="4834265" cy="4800600"/>
+            <a:ext cx="4754880" cy="2703894"/>
           </a:xfrm>
           <a:prstGeom prst="rect">
             <a:avLst/>
           </a:prstGeom>
         </p:spPr>
       </p:pic>
-      <p:sp>
-        <p:nvSpPr>
-          <p:cNvPr id="7" name="TextBox 6"/>
+      <p:pic>
+        <p:nvPicPr>
+          <p:cNvPr id="7" name="Picture 6" descr="Final check: a surname left in the instruction raises an alert"/>
+          <p:cNvPicPr>
+            <a:picLocks noChangeAspect="1"/>
+          </p:cNvPicPr>
+          <p:nvPr/>
+        </p:nvPicPr>
+        <p:blipFill>
+          <a:blip r:embed="rId5"/>
+          <a:stretch>
+            <a:fillRect/>
+          </a:stretch>
+        </p:blipFill>
+        <p:spPr>
+          <a:xfrm>
+            <a:off x="548640" y="4160520"/>
+            <a:ext cx="4754880" cy="1976308"/>
+          </a:xfrm>
+          <a:prstGeom prst="rect">
+            <a:avLst/>
+          </a:prstGeom>
+        </p:spPr>
+      </p:pic>
+      <p:sp>
+        <p:nvSpPr>
+          <p:cNvPr id="8" name="TextBox 7"/>
           <p:cNvSpPr txBox="1"/>
           <p:nvPr/>
         </p:nvSpPr>
         <p:spPr>
           <a:xfrm>
-            <a:off x="5623560" y="1463040"/>
-            <a:ext cx="5989320" cy="4572000"/>
+            <a:off x="5760720" y="1463040"/>
+            <a:ext cx="5852160" cy="4572000"/>
           </a:xfrm>
           <a:prstGeom prst="rect">
             <a:avLst/>
@@ -13996,14 +14092,14 @@
       </p:sp>
       <p:sp>
         <p:nvSpPr>
-          <p:cNvPr id="8" name="TextBox 7"/>
+          <p:cNvPr id="9" name="TextBox 8"/>
           <p:cNvSpPr txBox="1"/>
           <p:nvPr/>
         </p:nvSpPr>
         <p:spPr>
           <a:xfrm>
-            <a:off x="548640" y="6199632"/>
-            <a:ext cx="4937760" cy="182880"/>
+            <a:off x="548640" y="6172200"/>
+            <a:ext cx="4754880" cy="182880"/>
           </a:xfrm>
           <a:prstGeom prst="rect">
             <a:avLst/>
@@ -14022,13 +14118,13 @@
               </a:spcAft>
             </a:pPr>
             <a:r>
-              <a:rPr sz="900" b="0" i="0">
+              <a:rPr sz="1000" b="0" i="0">
                 <a:solidFill>
                   <a:srgbClr val="5B6675"/>
                 </a:solidFill>
                 <a:latin typeface="Calibri"/>
               </a:rPr>
-              <a:t>Screenshot of an earlier interface version, fictitious case</a:t>
+              <a:t>Fictitious sample case: Review (top), Final check alert (bottom)</a:t>
             </a:r>
           </a:p>
         </p:txBody>

</xml_diff>